<commit_message>
Refined slides and code
</commit_message>
<xml_diff>
--- a/firmgrid/submission/[TEAM_NAME]_FirmGrid_Poster.pptx
+++ b/firmgrid/submission/[TEAM_NAME]_FirmGrid_Poster.pptx
@@ -3311,45 +3311,6 @@
         <p:spPr>
           <a:xfrm>
             <a:off x="713232" y="2487168"/>
-            <a:ext cx="2322576" cy="731520"/>
-          </a:xfrm>
-          <a:prstGeom prst="rect">
-            <a:avLst/>
-          </a:prstGeom>
-          <a:noFill/>
-        </p:spPr>
-        <p:txBody>
-          <a:bodyPr wrap="square" anchor="t">
-            <a:spAutoFit/>
-          </a:bodyPr>
-          <a:lstStyle/>
-          <a:p>
-            <a:pPr algn="l">
-              <a:spcAft>
-                <a:spcPts val="600"/>
-              </a:spcAft>
-            </a:pPr>
-            <a:r>
-              <a:rPr sz="2600" b="1">
-                <a:solidFill>
-                  <a:srgbClr val="34D399"/>
-                </a:solidFill>
-                <a:latin typeface="Avenir Next"/>
-              </a:rPr>
-              <a:t>811 → 39</a:t>
-            </a:r>
-          </a:p>
-        </p:txBody>
-      </p:sp>
-      <p:sp>
-        <p:nvSpPr>
-          <p:cNvPr id="8" name="TextBox 7"/>
-          <p:cNvSpPr txBox="1"/>
-          <p:nvPr/>
-        </p:nvSpPr>
-        <p:spPr>
-          <a:xfrm>
-            <a:off x="713232" y="3108960"/>
             <a:ext cx="2322576" cy="777240"/>
           </a:xfrm>
           <a:prstGeom prst="rect">
@@ -3365,6 +3326,45 @@
           <a:p>
             <a:pPr algn="l">
               <a:spcAft>
+                <a:spcPts val="600"/>
+              </a:spcAft>
+            </a:pPr>
+            <a:r>
+              <a:rPr sz="2600" b="1">
+                <a:solidFill>
+                  <a:srgbClr val="34D399"/>
+                </a:solidFill>
+                <a:latin typeface="Avenir Next"/>
+              </a:rPr>
+              <a:t>703 → 20</a:t>
+            </a:r>
+          </a:p>
+        </p:txBody>
+      </p:sp>
+      <p:sp>
+        <p:nvSpPr>
+          <p:cNvPr id="8" name="TextBox 7"/>
+          <p:cNvSpPr txBox="1"/>
+          <p:nvPr/>
+        </p:nvSpPr>
+        <p:spPr>
+          <a:xfrm>
+            <a:off x="713232" y="3136392"/>
+            <a:ext cx="2322576" cy="777240"/>
+          </a:xfrm>
+          <a:prstGeom prst="rect">
+            <a:avLst/>
+          </a:prstGeom>
+          <a:noFill/>
+        </p:spPr>
+        <p:txBody>
+          <a:bodyPr wrap="square" anchor="t">
+            <a:spAutoFit/>
+          </a:bodyPr>
+          <a:lstStyle/>
+          <a:p>
+            <a:pPr algn="l">
+              <a:spcAft>
                 <a:spcPts val="0"/>
               </a:spcAft>
             </a:pPr>
@@ -3375,7 +3375,7 @@
                 </a:solidFill>
                 <a:latin typeface="Avenir Next"/>
               </a:rPr>
-              <a:t>kWh wasted on one feeder-day: baseline vs FirmGrid ON — 95% recovered</a:t>
+              <a:t>kWh wasted on one real Hanoi feeder-day: baseline vs FirmGrid ON — 97% recovered</a:t>
             </a:r>
           </a:p>
         </p:txBody>
@@ -3437,7 +3437,7 @@
         <p:spPr>
           <a:xfrm>
             <a:off x="3520440" y="2487168"/>
-            <a:ext cx="2322576" cy="731520"/>
+            <a:ext cx="2322576" cy="777240"/>
           </a:xfrm>
           <a:prstGeom prst="rect">
             <a:avLst/>
@@ -3475,7 +3475,7 @@
         </p:nvSpPr>
         <p:spPr>
           <a:xfrm>
-            <a:off x="3520440" y="3108960"/>
+            <a:off x="3520440" y="3136392"/>
             <a:ext cx="2322576" cy="777240"/>
           </a:xfrm>
           <a:prstGeom prst="rect">
@@ -3563,7 +3563,7 @@
         <p:spPr>
           <a:xfrm>
             <a:off x="6327648" y="2487168"/>
-            <a:ext cx="2322576" cy="731520"/>
+            <a:ext cx="2322576" cy="777240"/>
           </a:xfrm>
           <a:prstGeom prst="rect">
             <a:avLst/>
@@ -3601,7 +3601,7 @@
         </p:nvSpPr>
         <p:spPr>
           <a:xfrm>
-            <a:off x="6327648" y="3108960"/>
+            <a:off x="6327648" y="3136392"/>
             <a:ext cx="2322576" cy="777240"/>
           </a:xfrm>
           <a:prstGeom prst="rect">
@@ -3689,7 +3689,7 @@
         <p:spPr>
           <a:xfrm>
             <a:off x="9134856" y="2487168"/>
-            <a:ext cx="2322576" cy="731520"/>
+            <a:ext cx="2322576" cy="777240"/>
           </a:xfrm>
           <a:prstGeom prst="rect">
             <a:avLst/>
@@ -3714,7 +3714,7 @@
                 </a:solidFill>
                 <a:latin typeface="Avenir Next"/>
               </a:rPr>
-              <a:t>54% · $84</a:t>
+              <a:t>54% · $85</a:t>
             </a:r>
           </a:p>
         </p:txBody>
@@ -3727,7 +3727,7 @@
         </p:nvSpPr>
         <p:spPr>
           <a:xfrm>
-            <a:off x="9134856" y="3108960"/>
+            <a:off x="9134856" y="3136392"/>
             <a:ext cx="2322576" cy="777240"/>
           </a:xfrm>
           <a:prstGeom prst="rect">
@@ -3897,7 +3897,7 @@
                 </a:solidFill>
                 <a:latin typeface="Avenir Next"/>
               </a:rPr>
-              <a:t>predicts safe headroom per transformer (F1 0.80, held-out).</a:t>
+              <a:t>predicts safe headroom per transformer (F1 0.86 on real Hanoi weather).</a:t>
             </a:r>
           </a:p>
           <a:p>

</xml_diff>